<commit_message>
Ajusta proposta de edição de vídeo: logo, bio da equipe, SLA e plano avulso
- Move logo Recria para o topo do slide de capa
- Slide 2 passa a apresentar a equipe (Amanda ou colaborador supervisionado)
- Ajusta título e cards do slide "como funciona" e adiciona SLA de entrega
- Adiciona card de vídeo avulso (R$ 65) na página de investimento
- Remove travessões do texto e troca por vírgula/ponto
- Ajusta rodapé final para "Recria, Agência de Marketing"
</commit_message>
<xml_diff>
--- a/propostas/Recria - Proposta Edicao de Video.pptx
+++ b/propostas/Recria - Proposta Edicao de Video.pptx
@@ -1445,7 +1445,7 @@
         </p:blipFill>
         <p:spPr>
           <a:xfrm>
-            <a:off x="640080" y="3246120"/>
+            <a:off x="640080" y="457200"/>
             <a:ext cx="457200" cy="329184"/>
           </a:xfrm>
           <a:prstGeom prst="rect">
@@ -1461,7 +1461,7 @@
         </p:nvSpPr>
         <p:spPr>
           <a:xfrm>
-            <a:off x="1188720" y="3200400"/>
+            <a:off x="1188720" y="411480"/>
             <a:ext cx="2743200" cy="411480"/>
           </a:xfrm>
           <a:prstGeom prst="rect">
@@ -1500,7 +1500,7 @@
         </p:nvSpPr>
         <p:spPr>
           <a:xfrm>
-            <a:off x="640080" y="3703320"/>
+            <a:off x="640080" y="3840480"/>
             <a:ext cx="548640" cy="0"/>
           </a:xfrm>
           <a:prstGeom prst="line">
@@ -1523,7 +1523,7 @@
         </p:nvSpPr>
         <p:spPr>
           <a:xfrm>
-            <a:off x="640080" y="3840480"/>
+            <a:off x="640080" y="3977640"/>
             <a:ext cx="8686800" cy="640080"/>
           </a:xfrm>
           <a:prstGeom prst="rect">
@@ -1562,7 +1562,7 @@
         </p:nvSpPr>
         <p:spPr>
           <a:xfrm>
-            <a:off x="640080" y="4434840"/>
+            <a:off x="640080" y="4572000"/>
             <a:ext cx="8686800" cy="548640"/>
           </a:xfrm>
           <a:prstGeom prst="rect">
@@ -1601,7 +1601,7 @@
         </p:nvSpPr>
         <p:spPr>
           <a:xfrm>
-            <a:off x="640080" y="5074920"/>
+            <a:off x="640080" y="5212080"/>
             <a:ext cx="8686800" cy="274320"/>
           </a:xfrm>
           <a:prstGeom prst="rect">
@@ -1640,7 +1640,7 @@
         </p:nvSpPr>
         <p:spPr>
           <a:xfrm>
-            <a:off x="640080" y="5440680"/>
+            <a:off x="640080" y="5577840"/>
             <a:ext cx="7863840" cy="731520"/>
           </a:xfrm>
           <a:prstGeom prst="rect">
@@ -1778,7 +1778,7 @@
                 <a:ea typeface="Cambria" pitchFamily="34" charset="-122"/>
                 <a:cs typeface="Cambria" pitchFamily="34" charset="-120"/>
               </a:rPr>
-              <a:t>Amanda, fundadora da Recria</a:t>
+              <a:t>Equipe da Agência Recria</a:t>
             </a:r>
             <a:endParaRPr lang="en-US" sz="2800" dirty="0"/>
           </a:p>
@@ -1792,7 +1792,49 @@
         </p:nvSpPr>
         <p:spPr>
           <a:xfrm>
-            <a:off x="640080" y="1280160"/>
+            <a:off x="640080" y="1298448"/>
+            <a:ext cx="8961120" cy="457200"/>
+          </a:xfrm>
+          <a:prstGeom prst="rect">
+            <a:avLst/>
+          </a:prstGeom>
+          <a:noFill/>
+          <a:ln/>
+        </p:spPr>
+        <p:txBody>
+          <a:bodyPr wrap="square" lIns="0" tIns="0" rIns="0" bIns="0" rtlCol="0" anchor="ctr"/>
+          <a:lstStyle/>
+          <a:p>
+            <a:pPr indent="0" marL="0">
+              <a:lnSpc>
+                <a:spcPct val="120000"/>
+              </a:lnSpc>
+              <a:buNone/>
+            </a:pPr>
+            <a:r>
+              <a:rPr lang="en-US" sz="1250" dirty="0">
+                <a:solidFill>
+                  <a:srgbClr val="3A3A3A"/>
+                </a:solidFill>
+                <a:latin typeface="Calibri" pitchFamily="34" charset="0"/>
+                <a:ea typeface="Calibri" pitchFamily="34" charset="-122"/>
+                <a:cs typeface="Calibri" pitchFamily="34" charset="-120"/>
+              </a:rPr>
+              <a:t>Seus reels serão editados pela Amanda ou alguém da sua equipe, com sua supervisão. Amanda é a fundadora da Recria.</a:t>
+            </a:r>
+            <a:endParaRPr lang="en-US" sz="1250" dirty="0"/>
+          </a:p>
+        </p:txBody>
+      </p:sp>
+      <p:sp>
+        <p:nvSpPr>
+          <p:cNvPr id="5" name="Text 3"/>
+          <p:cNvSpPr/>
+          <p:nvPr/>
+        </p:nvSpPr>
+        <p:spPr>
+          <a:xfrm>
+            <a:off x="640080" y="1783080"/>
             <a:ext cx="8961120" cy="365760"/>
           </a:xfrm>
           <a:prstGeom prst="rect">
@@ -1817,7 +1859,7 @@
                 <a:ea typeface="Calibri" pitchFamily="34" charset="-122"/>
                 <a:cs typeface="Calibri" pitchFamily="34" charset="-120"/>
               </a:rPr>
-              <a:t>Antes de falar de planos, um panorama rápido de quem cuida do seu conteúdo.</a:t>
+              <a:t>Antes de falar de planos, um panorama rápido de quem estará à frente das edições do seu conteúdo.</a:t>
             </a:r>
             <a:endParaRPr lang="en-US" sz="1300" dirty="0"/>
           </a:p>
@@ -1825,13 +1867,13 @@
       </p:sp>
       <p:sp>
         <p:nvSpPr>
-          <p:cNvPr id="5" name="Shape 3"/>
-          <p:cNvSpPr/>
-          <p:nvPr/>
-        </p:nvSpPr>
-        <p:spPr>
-          <a:xfrm>
-            <a:off x="640080" y="1956816"/>
+          <p:cNvPr id="6" name="Shape 4"/>
+          <p:cNvSpPr/>
+          <p:nvPr/>
+        </p:nvSpPr>
+        <p:spPr>
+          <a:xfrm>
+            <a:off x="640080" y="2368296"/>
             <a:ext cx="128016" cy="128016"/>
           </a:xfrm>
           <a:prstGeom prst="rect">
@@ -1845,13 +1887,13 @@
       </p:sp>
       <p:sp>
         <p:nvSpPr>
-          <p:cNvPr id="6" name="Text 4"/>
-          <p:cNvSpPr/>
-          <p:nvPr/>
-        </p:nvSpPr>
-        <p:spPr>
-          <a:xfrm>
-            <a:off x="960120" y="1828800"/>
+          <p:cNvPr id="7" name="Text 5"/>
+          <p:cNvSpPr/>
+          <p:nvPr/>
+        </p:nvSpPr>
+        <p:spPr>
+          <a:xfrm>
+            <a:off x="960120" y="2240280"/>
             <a:ext cx="8138160" cy="502920"/>
           </a:xfrm>
           <a:prstGeom prst="rect">
@@ -1887,13 +1929,13 @@
       </p:sp>
       <p:sp>
         <p:nvSpPr>
-          <p:cNvPr id="7" name="Shape 5"/>
-          <p:cNvSpPr/>
-          <p:nvPr/>
-        </p:nvSpPr>
-        <p:spPr>
-          <a:xfrm>
-            <a:off x="640080" y="2578608"/>
+          <p:cNvPr id="8" name="Shape 6"/>
+          <p:cNvSpPr/>
+          <p:nvPr/>
+        </p:nvSpPr>
+        <p:spPr>
+          <a:xfrm>
+            <a:off x="640080" y="2990088"/>
             <a:ext cx="128016" cy="128016"/>
           </a:xfrm>
           <a:prstGeom prst="rect">
@@ -1907,13 +1949,13 @@
       </p:sp>
       <p:sp>
         <p:nvSpPr>
-          <p:cNvPr id="8" name="Text 6"/>
-          <p:cNvSpPr/>
-          <p:nvPr/>
-        </p:nvSpPr>
-        <p:spPr>
-          <a:xfrm>
-            <a:off x="960120" y="2450592"/>
+          <p:cNvPr id="9" name="Text 7"/>
+          <p:cNvSpPr/>
+          <p:nvPr/>
+        </p:nvSpPr>
+        <p:spPr>
+          <a:xfrm>
+            <a:off x="960120" y="2862072"/>
             <a:ext cx="8138160" cy="502920"/>
           </a:xfrm>
           <a:prstGeom prst="rect">
@@ -1949,13 +1991,13 @@
       </p:sp>
       <p:sp>
         <p:nvSpPr>
-          <p:cNvPr id="9" name="Shape 7"/>
-          <p:cNvSpPr/>
-          <p:nvPr/>
-        </p:nvSpPr>
-        <p:spPr>
-          <a:xfrm>
-            <a:off x="640080" y="3200400"/>
+          <p:cNvPr id="10" name="Shape 8"/>
+          <p:cNvSpPr/>
+          <p:nvPr/>
+        </p:nvSpPr>
+        <p:spPr>
+          <a:xfrm>
+            <a:off x="640080" y="3611880"/>
             <a:ext cx="128016" cy="128016"/>
           </a:xfrm>
           <a:prstGeom prst="rect">
@@ -1969,13 +2011,13 @@
       </p:sp>
       <p:sp>
         <p:nvSpPr>
-          <p:cNvPr id="10" name="Text 8"/>
-          <p:cNvSpPr/>
-          <p:nvPr/>
-        </p:nvSpPr>
-        <p:spPr>
-          <a:xfrm>
-            <a:off x="960120" y="3072384"/>
+          <p:cNvPr id="11" name="Text 9"/>
+          <p:cNvSpPr/>
+          <p:nvPr/>
+        </p:nvSpPr>
+        <p:spPr>
+          <a:xfrm>
+            <a:off x="960120" y="3483864"/>
             <a:ext cx="8138160" cy="502920"/>
           </a:xfrm>
           <a:prstGeom prst="rect">
@@ -2011,75 +2053,13 @@
       </p:sp>
       <p:sp>
         <p:nvSpPr>
-          <p:cNvPr id="11" name="Shape 9"/>
-          <p:cNvSpPr/>
-          <p:nvPr/>
-        </p:nvSpPr>
-        <p:spPr>
-          <a:xfrm>
-            <a:off x="640080" y="3822192"/>
-            <a:ext cx="128016" cy="128016"/>
-          </a:xfrm>
-          <a:prstGeom prst="rect">
-            <a:avLst/>
-          </a:prstGeom>
-          <a:solidFill>
-            <a:srgbClr val="C9A24B"/>
-          </a:solidFill>
-          <a:ln/>
-        </p:spPr>
-      </p:sp>
-      <p:sp>
-        <p:nvSpPr>
-          <p:cNvPr id="12" name="Text 10"/>
-          <p:cNvSpPr/>
-          <p:nvPr/>
-        </p:nvSpPr>
-        <p:spPr>
-          <a:xfrm>
-            <a:off x="960120" y="3694176"/>
-            <a:ext cx="8138160" cy="502920"/>
-          </a:xfrm>
-          <a:prstGeom prst="rect">
-            <a:avLst/>
-          </a:prstGeom>
-          <a:noFill/>
-          <a:ln/>
-        </p:spPr>
-        <p:txBody>
-          <a:bodyPr wrap="square" lIns="0" tIns="0" rIns="0" bIns="0" rtlCol="0" anchor="ctr"/>
-          <a:lstStyle/>
-          <a:p>
-            <a:pPr indent="0" marL="0">
-              <a:lnSpc>
-                <a:spcPct val="115000"/>
-              </a:lnSpc>
-              <a:buNone/>
-            </a:pPr>
-            <a:r>
-              <a:rPr lang="en-US" sz="1350" dirty="0">
-                <a:solidFill>
-                  <a:srgbClr val="3A3A3A"/>
-                </a:solidFill>
-                <a:latin typeface="Calibri" pitchFamily="34" charset="0"/>
-                <a:ea typeface="Calibri" pitchFamily="34" charset="-122"/>
-                <a:cs typeface="Calibri" pitchFamily="34" charset="-120"/>
-              </a:rPr>
-              <a:t>Fundadora da Recria desde 2024, cem por cento dedicada à agência.</a:t>
-            </a:r>
-            <a:endParaRPr lang="en-US" sz="1350" dirty="0"/>
-          </a:p>
-        </p:txBody>
-      </p:sp>
-      <p:sp>
-        <p:nvSpPr>
-          <p:cNvPr id="13" name="Shape 11"/>
-          <p:cNvSpPr/>
-          <p:nvPr/>
-        </p:nvSpPr>
-        <p:spPr>
-          <a:xfrm>
-            <a:off x="640080" y="4498848"/>
+          <p:cNvPr id="12" name="Shape 10"/>
+          <p:cNvSpPr/>
+          <p:nvPr/>
+        </p:nvSpPr>
+        <p:spPr>
+          <a:xfrm>
+            <a:off x="640080" y="4288536"/>
             <a:ext cx="8138160" cy="1234440"/>
           </a:xfrm>
           <a:prstGeom prst="roundRect">
@@ -2100,52 +2080,52 @@
       </p:sp>
       <p:sp>
         <p:nvSpPr>
+          <p:cNvPr id="13" name="Text 11"/>
+          <p:cNvSpPr/>
+          <p:nvPr/>
+        </p:nvSpPr>
+        <p:spPr>
+          <a:xfrm>
+            <a:off x="914400" y="4425696"/>
+            <a:ext cx="7589520" cy="274320"/>
+          </a:xfrm>
+          <a:prstGeom prst="rect">
+            <a:avLst/>
+          </a:prstGeom>
+          <a:noFill/>
+          <a:ln/>
+        </p:spPr>
+        <p:txBody>
+          <a:bodyPr wrap="square" lIns="0" tIns="0" rIns="0" bIns="0" rtlCol="0" anchor="ctr"/>
+          <a:lstStyle/>
+          <a:p>
+            <a:pPr indent="0" marL="0">
+              <a:buNone/>
+            </a:pPr>
+            <a:r>
+              <a:rPr lang="en-US" sz="1300" b="1" dirty="0">
+                <a:solidFill>
+                  <a:srgbClr val="0D0D0D"/>
+                </a:solidFill>
+                <a:latin typeface="Calibri" pitchFamily="34" charset="0"/>
+                <a:ea typeface="Calibri" pitchFamily="34" charset="-122"/>
+                <a:cs typeface="Calibri" pitchFamily="34" charset="-120"/>
+              </a:rPr>
+              <a:t>O que isso significa para você</a:t>
+            </a:r>
+            <a:endParaRPr lang="en-US" sz="1300" dirty="0"/>
+          </a:p>
+        </p:txBody>
+      </p:sp>
+      <p:sp>
+        <p:nvSpPr>
           <p:cNvPr id="14" name="Text 12"/>
           <p:cNvSpPr/>
           <p:nvPr/>
         </p:nvSpPr>
         <p:spPr>
           <a:xfrm>
-            <a:off x="914400" y="4636008"/>
-            <a:ext cx="7589520" cy="274320"/>
-          </a:xfrm>
-          <a:prstGeom prst="rect">
-            <a:avLst/>
-          </a:prstGeom>
-          <a:noFill/>
-          <a:ln/>
-        </p:spPr>
-        <p:txBody>
-          <a:bodyPr wrap="square" lIns="0" tIns="0" rIns="0" bIns="0" rtlCol="0" anchor="ctr"/>
-          <a:lstStyle/>
-          <a:p>
-            <a:pPr indent="0" marL="0">
-              <a:buNone/>
-            </a:pPr>
-            <a:r>
-              <a:rPr lang="en-US" sz="1300" b="1" dirty="0">
-                <a:solidFill>
-                  <a:srgbClr val="0D0D0D"/>
-                </a:solidFill>
-                <a:latin typeface="Calibri" pitchFamily="34" charset="0"/>
-                <a:ea typeface="Calibri" pitchFamily="34" charset="-122"/>
-                <a:cs typeface="Calibri" pitchFamily="34" charset="-120"/>
-              </a:rPr>
-              <a:t>O que isso significa para você</a:t>
-            </a:r>
-            <a:endParaRPr lang="en-US" sz="1300" dirty="0"/>
-          </a:p>
-        </p:txBody>
-      </p:sp>
-      <p:sp>
-        <p:nvSpPr>
-          <p:cNvPr id="15" name="Text 13"/>
-          <p:cNvSpPr/>
-          <p:nvPr/>
-        </p:nvSpPr>
-        <p:spPr>
-          <a:xfrm>
-            <a:off x="914400" y="4937760"/>
+            <a:off x="914400" y="4727448"/>
             <a:ext cx="7589520" cy="685800"/>
           </a:xfrm>
           <a:prstGeom prst="rect">
@@ -2173,7 +2153,7 @@
                 <a:ea typeface="Calibri" pitchFamily="34" charset="-122"/>
                 <a:cs typeface="Calibri" pitchFamily="34" charset="-120"/>
               </a:rPr>
-              <a:t>Reels editados com visão de estratégia, comunicação e ritmo, não só corte técnico — pensados para reter audiência e gerar resultado, um trabalho a quatro mãos entre a Recria e a sua equipe.</a:t>
+              <a:t>Reels editados com visão de estratégia, comunicação e ritmo, não só corte técnico, pensados para reter audiência e gerar resultado, um trabalho a quatro mãos entre a Recria e a sua equipe.</a:t>
             </a:r>
             <a:endParaRPr lang="en-US" sz="1250" dirty="0"/>
           </a:p>
@@ -2181,7 +2161,7 @@
       </p:sp>
       <p:sp>
         <p:nvSpPr>
-          <p:cNvPr id="16" name="Text 14"/>
+          <p:cNvPr id="15" name="Text 13"/>
           <p:cNvSpPr/>
           <p:nvPr/>
         </p:nvSpPr>
@@ -2513,7 +2493,7 @@
                 <a:ea typeface="Calibri" pitchFamily="34" charset="-122"/>
                 <a:cs typeface="Calibri" pitchFamily="34" charset="-120"/>
               </a:rPr>
-              <a:t>Uma lista organizada com exemplos reais de edição entregues pela Recria — variedade de nichos, formatos e estilos de corte.</a:t>
+              <a:t>Uma lista organizada com exemplos reais de edição entregues pela Recria, com variedade de nichos, formatos e estilos de corte.</a:t>
             </a:r>
             <a:endParaRPr lang="en-US" sz="1250" dirty="0"/>
           </a:p>
@@ -2734,7 +2714,7 @@
                 <a:ea typeface="Cambria" pitchFamily="34" charset="-122"/>
                 <a:cs typeface="Cambria" pitchFamily="34" charset="-120"/>
               </a:rPr>
-              <a:t>Entrega mensal, sem complicação</a:t>
+              <a:t>Entrega mensal ou pontual</a:t>
             </a:r>
             <a:endParaRPr lang="en-US" sz="2800" dirty="0"/>
           </a:p>
@@ -2749,11 +2729,11 @@
         <p:spPr>
           <a:xfrm>
             <a:off x="640080" y="1600200"/>
-            <a:ext cx="2587752" cy="2651760"/>
+            <a:ext cx="2587752" cy="2194560"/>
           </a:xfrm>
           <a:prstGeom prst="roundRect">
             <a:avLst>
-              <a:gd name="adj" fmla="val 2120"/>
+              <a:gd name="adj" fmla="val 2500"/>
             </a:avLst>
           </a:prstGeom>
           <a:solidFill>
@@ -2839,7 +2819,7 @@
                 <a:ea typeface="Calibri" pitchFamily="34" charset="-122"/>
                 <a:cs typeface="Calibri" pitchFamily="34" charset="-120"/>
               </a:rPr>
-              <a:t>Envio do bruto</a:t>
+              <a:t>Envio do vídeo bruto</a:t>
             </a:r>
             <a:endParaRPr lang="en-US" sz="1500" dirty="0"/>
           </a:p>
@@ -2854,7 +2834,7 @@
         <p:spPr>
           <a:xfrm>
             <a:off x="868680" y="2880360"/>
-            <a:ext cx="2130552" cy="1188720"/>
+            <a:ext cx="2130552" cy="822960"/>
           </a:xfrm>
           <a:prstGeom prst="rect">
             <a:avLst/>
@@ -2896,11 +2876,11 @@
         <p:spPr>
           <a:xfrm>
             <a:off x="3483864" y="1600200"/>
-            <a:ext cx="2587752" cy="2651760"/>
+            <a:ext cx="2587752" cy="2194560"/>
           </a:xfrm>
           <a:prstGeom prst="roundRect">
             <a:avLst>
-              <a:gd name="adj" fmla="val 2120"/>
+              <a:gd name="adj" fmla="val 2500"/>
             </a:avLst>
           </a:prstGeom>
           <a:solidFill>
@@ -3001,7 +2981,7 @@
         <p:spPr>
           <a:xfrm>
             <a:off x="3712464" y="2880360"/>
-            <a:ext cx="2130552" cy="1188720"/>
+            <a:ext cx="2130552" cy="822960"/>
           </a:xfrm>
           <a:prstGeom prst="rect">
             <a:avLst/>
@@ -3043,11 +3023,11 @@
         <p:spPr>
           <a:xfrm>
             <a:off x="6327648" y="1600200"/>
-            <a:ext cx="2587752" cy="2651760"/>
+            <a:ext cx="2587752" cy="2194560"/>
           </a:xfrm>
           <a:prstGeom prst="roundRect">
             <a:avLst>
-              <a:gd name="adj" fmla="val 2120"/>
+              <a:gd name="adj" fmla="val 2500"/>
             </a:avLst>
           </a:prstGeom>
           <a:solidFill>
@@ -3148,7 +3128,7 @@
         <p:spPr>
           <a:xfrm>
             <a:off x="6556248" y="2880360"/>
-            <a:ext cx="2130552" cy="1188720"/>
+            <a:ext cx="2130552" cy="822960"/>
           </a:xfrm>
           <a:prstGeom prst="rect">
             <a:avLst/>
@@ -3189,12 +3169,12 @@
         </p:nvSpPr>
         <p:spPr>
           <a:xfrm>
-            <a:off x="640080" y="4526280"/>
-            <a:ext cx="8138160" cy="777240"/>
+            <a:off x="640080" y="4023360"/>
+            <a:ext cx="8138160" cy="548640"/>
           </a:xfrm>
           <a:prstGeom prst="roundRect">
             <a:avLst>
-              <a:gd name="adj" fmla="val 7059"/>
+              <a:gd name="adj" fmla="val 10000"/>
             </a:avLst>
           </a:prstGeom>
           <a:solidFill>
@@ -3211,8 +3191,83 @@
         </p:nvSpPr>
         <p:spPr>
           <a:xfrm>
+            <a:off x="914400" y="4023360"/>
+            <a:ext cx="7589520" cy="548640"/>
+          </a:xfrm>
+          <a:prstGeom prst="rect">
+            <a:avLst/>
+          </a:prstGeom>
+          <a:noFill/>
+          <a:ln/>
+        </p:spPr>
+        <p:txBody>
+          <a:bodyPr wrap="square" lIns="0" tIns="0" rIns="0" bIns="0" rtlCol="0" anchor="ctr"/>
+          <a:lstStyle/>
+          <a:p>
+            <a:pPr indent="0" marL="0">
+              <a:buNone/>
+            </a:pPr>
+            <a:r>
+              <a:rPr lang="en-US" sz="1250" b="1" dirty="0">
+                <a:solidFill>
+                  <a:srgbClr val="3A3A3A"/>
+                </a:solidFill>
+                <a:latin typeface="Calibri" pitchFamily="34" charset="0"/>
+                <a:ea typeface="Calibri" pitchFamily="34" charset="-122"/>
+                <a:cs typeface="Calibri" pitchFamily="34" charset="-120"/>
+              </a:rPr>
+              <a:t>OBS.: </a:t>
+            </a:r>
+            <a:pPr indent="0" marL="0">
+              <a:buNone/>
+            </a:pPr>
+            <a:r>
+              <a:rPr lang="en-US" sz="1250" dirty="0">
+                <a:solidFill>
+                  <a:srgbClr val="3A3A3A"/>
+                </a:solidFill>
+                <a:latin typeface="Calibri" pitchFamily="34" charset="0"/>
+                <a:ea typeface="Calibri" pitchFamily="34" charset="-122"/>
+                <a:cs typeface="Calibri" pitchFamily="34" charset="-120"/>
+              </a:rPr>
+              <a:t>SLA de até 3 dias úteis para 1 vídeo e de 5 dias úteis para 4 vídeos.</a:t>
+            </a:r>
+            <a:endParaRPr lang="en-US" sz="1250" dirty="0"/>
+          </a:p>
+        </p:txBody>
+      </p:sp>
+      <p:sp>
+        <p:nvSpPr>
+          <p:cNvPr id="18" name="Shape 16"/>
+          <p:cNvSpPr/>
+          <p:nvPr/>
+        </p:nvSpPr>
+        <p:spPr>
+          <a:xfrm>
+            <a:off x="640080" y="4663440"/>
+            <a:ext cx="8138160" cy="548640"/>
+          </a:xfrm>
+          <a:prstGeom prst="roundRect">
+            <a:avLst>
+              <a:gd name="adj" fmla="val 10000"/>
+            </a:avLst>
+          </a:prstGeom>
+          <a:solidFill>
+            <a:srgbClr val="E6E0D0"/>
+          </a:solidFill>
+          <a:ln/>
+        </p:spPr>
+      </p:sp>
+      <p:sp>
+        <p:nvSpPr>
+          <p:cNvPr id="19" name="Text 17"/>
+          <p:cNvSpPr/>
+          <p:nvPr/>
+        </p:nvSpPr>
+        <p:spPr>
+          <a:xfrm>
             <a:off x="914400" y="4663440"/>
-            <a:ext cx="7589520" cy="502920"/>
+            <a:ext cx="7589520" cy="548640"/>
           </a:xfrm>
           <a:prstGeom prst="rect">
             <a:avLst/>
@@ -3244,7 +3299,7 @@
       </p:sp>
       <p:sp>
         <p:nvSpPr>
-          <p:cNvPr id="18" name="Text 16"/>
+          <p:cNvPr id="20" name="Text 18"/>
           <p:cNvSpPr/>
           <p:nvPr/>
         </p:nvSpPr>
@@ -3424,7 +3479,7 @@
                 <a:ea typeface="Calibri" pitchFamily="34" charset="-122"/>
                 <a:cs typeface="Calibri" pitchFamily="34" charset="-120"/>
               </a:rPr>
-              <a:t>Valor avulso de R$ 60 por reel. Em pacote mensal, cada reel sai por R$ 50, já com desconto.</a:t>
+              <a:t>Valor avulso de R$ 65 por reel. Em pacote mensal, cada reel sai por R$ 50, já com desconto.</a:t>
             </a:r>
             <a:endParaRPr lang="en-US" sz="1300" dirty="0"/>
           </a:p>
@@ -3439,11 +3494,11 @@
         <p:spPr>
           <a:xfrm>
             <a:off x="640080" y="1828800"/>
-            <a:ext cx="3931920" cy="3017520"/>
+            <a:ext cx="2624328" cy="3017520"/>
           </a:xfrm>
           <a:prstGeom prst="roundRect">
             <a:avLst>
-              <a:gd name="adj" fmla="val 2121"/>
+              <a:gd name="adj" fmla="val 2439"/>
             </a:avLst>
           </a:prstGeom>
           <a:solidFill>
@@ -3465,24 +3520,24 @@
         </p:nvSpPr>
         <p:spPr>
           <a:xfrm>
-            <a:off x="914400" y="2103120"/>
-            <a:ext cx="3383280" cy="365760"/>
-          </a:xfrm>
-          <a:prstGeom prst="rect">
-            <a:avLst/>
-          </a:prstGeom>
-          <a:noFill/>
-          <a:ln/>
-        </p:spPr>
-        <p:txBody>
-          <a:bodyPr wrap="square" lIns="0" tIns="0" rIns="0" bIns="0" rtlCol="0" anchor="ctr"/>
-          <a:lstStyle/>
-          <a:p>
-            <a:pPr indent="0" marL="0">
-              <a:buNone/>
-            </a:pPr>
-            <a:r>
-              <a:rPr lang="en-US" sz="1700" b="1" dirty="0">
+            <a:off x="868680" y="2103120"/>
+            <a:ext cx="2167128" cy="365760"/>
+          </a:xfrm>
+          <a:prstGeom prst="rect">
+            <a:avLst/>
+          </a:prstGeom>
+          <a:noFill/>
+          <a:ln/>
+        </p:spPr>
+        <p:txBody>
+          <a:bodyPr wrap="square" lIns="0" tIns="0" rIns="0" bIns="0" rtlCol="0" anchor="ctr"/>
+          <a:lstStyle/>
+          <a:p>
+            <a:pPr indent="0" marL="0">
+              <a:buNone/>
+            </a:pPr>
+            <a:r>
+              <a:rPr lang="en-US" sz="1550" b="1" dirty="0">
                 <a:solidFill>
                   <a:srgbClr val="0D0D0D"/>
                 </a:solidFill>
@@ -3492,7 +3547,7 @@
               </a:rPr>
               <a:t>Pacote 4 reels/mês</a:t>
             </a:r>
-            <a:endParaRPr lang="en-US" sz="1700" dirty="0"/>
+            <a:endParaRPr lang="en-US" sz="1550" dirty="0"/>
           </a:p>
         </p:txBody>
       </p:sp>
@@ -3504,24 +3559,24 @@
         </p:nvSpPr>
         <p:spPr>
           <a:xfrm>
-            <a:off x="914400" y="2606040"/>
-            <a:ext cx="3383280" cy="320040"/>
-          </a:xfrm>
-          <a:prstGeom prst="rect">
-            <a:avLst/>
-          </a:prstGeom>
-          <a:noFill/>
-          <a:ln/>
-        </p:spPr>
-        <p:txBody>
-          <a:bodyPr wrap="square" lIns="0" tIns="0" rIns="0" bIns="0" rtlCol="0" anchor="ctr"/>
-          <a:lstStyle/>
-          <a:p>
-            <a:pPr indent="0" marL="0">
-              <a:buNone/>
-            </a:pPr>
-            <a:r>
-              <a:rPr lang="en-US" sz="1250" dirty="0">
+            <a:off x="868680" y="2578608"/>
+            <a:ext cx="2167128" cy="320040"/>
+          </a:xfrm>
+          <a:prstGeom prst="rect">
+            <a:avLst/>
+          </a:prstGeom>
+          <a:noFill/>
+          <a:ln/>
+        </p:spPr>
+        <p:txBody>
+          <a:bodyPr wrap="square" lIns="0" tIns="0" rIns="0" bIns="0" rtlCol="0" anchor="ctr"/>
+          <a:lstStyle/>
+          <a:p>
+            <a:pPr indent="0" marL="0">
+              <a:buNone/>
+            </a:pPr>
+            <a:r>
+              <a:rPr lang="en-US" sz="1100" dirty="0">
                 <a:solidFill>
                   <a:srgbClr val="3A3A3A"/>
                 </a:solidFill>
@@ -3531,7 +3586,7 @@
               </a:rPr>
               <a:t>›  4 reels editados por mês</a:t>
             </a:r>
-            <a:endParaRPr lang="en-US" sz="1250" dirty="0"/>
+            <a:endParaRPr lang="en-US" sz="1100" dirty="0"/>
           </a:p>
         </p:txBody>
       </p:sp>
@@ -3543,24 +3598,24 @@
         </p:nvSpPr>
         <p:spPr>
           <a:xfrm>
-            <a:off x="914400" y="2971800"/>
-            <a:ext cx="3383280" cy="320040"/>
-          </a:xfrm>
-          <a:prstGeom prst="rect">
-            <a:avLst/>
-          </a:prstGeom>
-          <a:noFill/>
-          <a:ln/>
-        </p:spPr>
-        <p:txBody>
-          <a:bodyPr wrap="square" lIns="0" tIns="0" rIns="0" bIns="0" rtlCol="0" anchor="ctr"/>
-          <a:lstStyle/>
-          <a:p>
-            <a:pPr indent="0" marL="0">
-              <a:buNone/>
-            </a:pPr>
-            <a:r>
-              <a:rPr lang="en-US" sz="1250" dirty="0">
+            <a:off x="868680" y="2916936"/>
+            <a:ext cx="2167128" cy="320040"/>
+          </a:xfrm>
+          <a:prstGeom prst="rect">
+            <a:avLst/>
+          </a:prstGeom>
+          <a:noFill/>
+          <a:ln/>
+        </p:spPr>
+        <p:txBody>
+          <a:bodyPr wrap="square" lIns="0" tIns="0" rIns="0" bIns="0" rtlCol="0" anchor="ctr"/>
+          <a:lstStyle/>
+          <a:p>
+            <a:pPr indent="0" marL="0">
+              <a:buNone/>
+            </a:pPr>
+            <a:r>
+              <a:rPr lang="en-US" sz="1100" dirty="0">
                 <a:solidFill>
                   <a:srgbClr val="3A3A3A"/>
                 </a:solidFill>
@@ -3570,7 +3625,7 @@
               </a:rPr>
               <a:t>›  Cortes, ritmo e legendas</a:t>
             </a:r>
-            <a:endParaRPr lang="en-US" sz="1250" dirty="0"/>
+            <a:endParaRPr lang="en-US" sz="1100" dirty="0"/>
           </a:p>
         </p:txBody>
       </p:sp>
@@ -3582,24 +3637,24 @@
         </p:nvSpPr>
         <p:spPr>
           <a:xfrm>
-            <a:off x="914400" y="3337560"/>
-            <a:ext cx="3383280" cy="320040"/>
-          </a:xfrm>
-          <a:prstGeom prst="rect">
-            <a:avLst/>
-          </a:prstGeom>
-          <a:noFill/>
-          <a:ln/>
-        </p:spPr>
-        <p:txBody>
-          <a:bodyPr wrap="square" lIns="0" tIns="0" rIns="0" bIns="0" rtlCol="0" anchor="ctr"/>
-          <a:lstStyle/>
-          <a:p>
-            <a:pPr indent="0" marL="0">
-              <a:buNone/>
-            </a:pPr>
-            <a:r>
-              <a:rPr lang="en-US" sz="1250" dirty="0">
+            <a:off x="868680" y="3255264"/>
+            <a:ext cx="2167128" cy="320040"/>
+          </a:xfrm>
+          <a:prstGeom prst="rect">
+            <a:avLst/>
+          </a:prstGeom>
+          <a:noFill/>
+          <a:ln/>
+        </p:spPr>
+        <p:txBody>
+          <a:bodyPr wrap="square" lIns="0" tIns="0" rIns="0" bIns="0" rtlCol="0" anchor="ctr"/>
+          <a:lstStyle/>
+          <a:p>
+            <a:pPr indent="0" marL="0">
+              <a:buNone/>
+            </a:pPr>
+            <a:r>
+              <a:rPr lang="en-US" sz="1100" dirty="0">
                 <a:solidFill>
                   <a:srgbClr val="3A3A3A"/>
                 </a:solidFill>
@@ -3609,7 +3664,7 @@
               </a:rPr>
               <a:t>›  R$ 50 por reel no pacote</a:t>
             </a:r>
-            <a:endParaRPr lang="en-US" sz="1250" dirty="0"/>
+            <a:endParaRPr lang="en-US" sz="1100" dirty="0"/>
           </a:p>
         </p:txBody>
       </p:sp>
@@ -3621,8 +3676,8 @@
         </p:nvSpPr>
         <p:spPr>
           <a:xfrm>
-            <a:off x="914400" y="3749040"/>
-            <a:ext cx="3383280" cy="0"/>
+            <a:off x="868680" y="3639312"/>
+            <a:ext cx="2167128" cy="0"/>
           </a:xfrm>
           <a:prstGeom prst="line">
             <a:avLst/>
@@ -3644,24 +3699,24 @@
         </p:nvSpPr>
         <p:spPr>
           <a:xfrm>
-            <a:off x="914400" y="3886200"/>
-            <a:ext cx="3383280" cy="228600"/>
-          </a:xfrm>
-          <a:prstGeom prst="rect">
-            <a:avLst/>
-          </a:prstGeom>
-          <a:noFill/>
-          <a:ln/>
-        </p:spPr>
-        <p:txBody>
-          <a:bodyPr wrap="square" lIns="0" tIns="0" rIns="0" bIns="0" rtlCol="0" anchor="ctr"/>
-          <a:lstStyle/>
-          <a:p>
-            <a:pPr indent="0" marL="0">
-              <a:buNone/>
-            </a:pPr>
-            <a:r>
-              <a:rPr lang="en-US" sz="1000" spc="100" kern="0" dirty="0">
+            <a:off x="868680" y="3776472"/>
+            <a:ext cx="2167128" cy="228600"/>
+          </a:xfrm>
+          <a:prstGeom prst="rect">
+            <a:avLst/>
+          </a:prstGeom>
+          <a:noFill/>
+          <a:ln/>
+        </p:spPr>
+        <p:txBody>
+          <a:bodyPr wrap="square" lIns="0" tIns="0" rIns="0" bIns="0" rtlCol="0" anchor="ctr"/>
+          <a:lstStyle/>
+          <a:p>
+            <a:pPr indent="0" marL="0">
+              <a:buNone/>
+            </a:pPr>
+            <a:r>
+              <a:rPr lang="en-US" sz="950" spc="100" kern="0" dirty="0">
                 <a:solidFill>
                   <a:srgbClr val="5A5A5A"/>
                 </a:solidFill>
@@ -3671,7 +3726,7 @@
               </a:rPr>
               <a:t>A PARTIR DE</a:t>
             </a:r>
-            <a:endParaRPr lang="en-US" sz="1000" dirty="0"/>
+            <a:endParaRPr lang="en-US" sz="950" dirty="0"/>
           </a:p>
         </p:txBody>
       </p:sp>
@@ -3683,24 +3738,24 @@
         </p:nvSpPr>
         <p:spPr>
           <a:xfrm>
-            <a:off x="914400" y="4087368"/>
-            <a:ext cx="3383280" cy="457200"/>
-          </a:xfrm>
-          <a:prstGeom prst="rect">
-            <a:avLst/>
-          </a:prstGeom>
-          <a:noFill/>
-          <a:ln/>
-        </p:spPr>
-        <p:txBody>
-          <a:bodyPr wrap="square" lIns="0" tIns="0" rIns="0" bIns="0" rtlCol="0" anchor="ctr"/>
-          <a:lstStyle/>
-          <a:p>
-            <a:pPr indent="0" marL="0">
-              <a:buNone/>
-            </a:pPr>
-            <a:r>
-              <a:rPr lang="en-US" sz="2600" b="1" dirty="0">
+            <a:off x="868680" y="3977640"/>
+            <a:ext cx="2167128" cy="411480"/>
+          </a:xfrm>
+          <a:prstGeom prst="rect">
+            <a:avLst/>
+          </a:prstGeom>
+          <a:noFill/>
+          <a:ln/>
+        </p:spPr>
+        <p:txBody>
+          <a:bodyPr wrap="square" lIns="0" tIns="0" rIns="0" bIns="0" rtlCol="0" anchor="ctr"/>
+          <a:lstStyle/>
+          <a:p>
+            <a:pPr indent="0" marL="0">
+              <a:buNone/>
+            </a:pPr>
+            <a:r>
+              <a:rPr lang="en-US" sz="2200" b="1" dirty="0">
                 <a:solidFill>
                   <a:srgbClr val="0D0D0D"/>
                 </a:solidFill>
@@ -3714,7 +3769,7 @@
               <a:buNone/>
             </a:pPr>
             <a:r>
-              <a:rPr lang="en-US" sz="1300" dirty="0">
+              <a:rPr lang="en-US" sz="1200" dirty="0">
                 <a:solidFill>
                   <a:srgbClr val="5A5A5A"/>
                 </a:solidFill>
@@ -3724,7 +3779,7 @@
               </a:rPr>
               <a:t>/mês</a:t>
             </a:r>
-            <a:endParaRPr lang="en-US" sz="2600" dirty="0"/>
+            <a:endParaRPr lang="en-US" sz="2200" dirty="0"/>
           </a:p>
         </p:txBody>
       </p:sp>
@@ -3736,24 +3791,24 @@
         </p:nvSpPr>
         <p:spPr>
           <a:xfrm>
-            <a:off x="914400" y="4572000"/>
-            <a:ext cx="3383280" cy="274320"/>
-          </a:xfrm>
-          <a:prstGeom prst="rect">
-            <a:avLst/>
-          </a:prstGeom>
-          <a:noFill/>
-          <a:ln/>
-        </p:spPr>
-        <p:txBody>
-          <a:bodyPr wrap="square" lIns="0" tIns="0" rIns="0" bIns="0" rtlCol="0" anchor="ctr"/>
-          <a:lstStyle/>
-          <a:p>
-            <a:pPr indent="0" marL="0">
-              <a:buNone/>
-            </a:pPr>
-            <a:r>
-              <a:rPr lang="en-US" sz="1050" i="1" dirty="0">
+            <a:off x="868680" y="4416552"/>
+            <a:ext cx="2167128" cy="274320"/>
+          </a:xfrm>
+          <a:prstGeom prst="rect">
+            <a:avLst/>
+          </a:prstGeom>
+          <a:noFill/>
+          <a:ln/>
+        </p:spPr>
+        <p:txBody>
+          <a:bodyPr wrap="square" lIns="0" tIns="0" rIns="0" bIns="0" rtlCol="0" anchor="ctr"/>
+          <a:lstStyle/>
+          <a:p>
+            <a:pPr indent="0" marL="0">
+              <a:buNone/>
+            </a:pPr>
+            <a:r>
+              <a:rPr lang="en-US" sz="950" i="1" dirty="0">
                 <a:solidFill>
                   <a:srgbClr val="5A5A5A"/>
                 </a:solidFill>
@@ -3763,7 +3818,7 @@
               </a:rPr>
               <a:t>equivalente a R$ 50 por reel</a:t>
             </a:r>
-            <a:endParaRPr lang="en-US" sz="1050" dirty="0"/>
+            <a:endParaRPr lang="en-US" sz="950" dirty="0"/>
           </a:p>
         </p:txBody>
       </p:sp>
@@ -3775,12 +3830,12 @@
         </p:nvSpPr>
         <p:spPr>
           <a:xfrm>
-            <a:off x="4846320" y="1828800"/>
-            <a:ext cx="3931920" cy="3017520"/>
+            <a:off x="3483864" y="1828800"/>
+            <a:ext cx="2624328" cy="3017520"/>
           </a:xfrm>
           <a:prstGeom prst="roundRect">
             <a:avLst>
-              <a:gd name="adj" fmla="val 2121"/>
+              <a:gd name="adj" fmla="val 2439"/>
             </a:avLst>
           </a:prstGeom>
           <a:solidFill>
@@ -3802,8 +3857,8 @@
         </p:nvSpPr>
         <p:spPr>
           <a:xfrm>
-            <a:off x="7040880" y="1664208"/>
-            <a:ext cx="1554480" cy="329184"/>
+            <a:off x="4553712" y="1664208"/>
+            <a:ext cx="1371600" cy="310896"/>
           </a:xfrm>
           <a:prstGeom prst="roundRect">
             <a:avLst>
@@ -3824,8 +3879,8 @@
         </p:nvSpPr>
         <p:spPr>
           <a:xfrm>
-            <a:off x="7040880" y="1664208"/>
-            <a:ext cx="1554480" cy="329184"/>
+            <a:off x="4553712" y="1664208"/>
+            <a:ext cx="1371600" cy="310896"/>
           </a:xfrm>
           <a:prstGeom prst="rect">
             <a:avLst/>
@@ -3841,7 +3896,7 @@
               <a:buNone/>
             </a:pPr>
             <a:r>
-              <a:rPr lang="en-US" sz="1000" b="1" spc="100" kern="0" dirty="0">
+              <a:rPr lang="en-US" sz="900" b="1" spc="50" kern="0" dirty="0">
                 <a:solidFill>
                   <a:srgbClr val="0D0D0D"/>
                 </a:solidFill>
@@ -3851,7 +3906,7 @@
               </a:rPr>
               <a:t>RECOMENDADO</a:t>
             </a:r>
-            <a:endParaRPr lang="en-US" sz="1000" dirty="0"/>
+            <a:endParaRPr lang="en-US" sz="900" dirty="0"/>
           </a:p>
         </p:txBody>
       </p:sp>
@@ -3863,24 +3918,24 @@
         </p:nvSpPr>
         <p:spPr>
           <a:xfrm>
-            <a:off x="5120640" y="2103120"/>
-            <a:ext cx="3383280" cy="365760"/>
-          </a:xfrm>
-          <a:prstGeom prst="rect">
-            <a:avLst/>
-          </a:prstGeom>
-          <a:noFill/>
-          <a:ln/>
-        </p:spPr>
-        <p:txBody>
-          <a:bodyPr wrap="square" lIns="0" tIns="0" rIns="0" bIns="0" rtlCol="0" anchor="ctr"/>
-          <a:lstStyle/>
-          <a:p>
-            <a:pPr indent="0" marL="0">
-              <a:buNone/>
-            </a:pPr>
-            <a:r>
-              <a:rPr lang="en-US" sz="1700" b="1" dirty="0">
+            <a:off x="3712464" y="2103120"/>
+            <a:ext cx="2167128" cy="365760"/>
+          </a:xfrm>
+          <a:prstGeom prst="rect">
+            <a:avLst/>
+          </a:prstGeom>
+          <a:noFill/>
+          <a:ln/>
+        </p:spPr>
+        <p:txBody>
+          <a:bodyPr wrap="square" lIns="0" tIns="0" rIns="0" bIns="0" rtlCol="0" anchor="ctr"/>
+          <a:lstStyle/>
+          <a:p>
+            <a:pPr indent="0" marL="0">
+              <a:buNone/>
+            </a:pPr>
+            <a:r>
+              <a:rPr lang="en-US" sz="1550" b="1" dirty="0">
                 <a:solidFill>
                   <a:srgbClr val="0D0D0D"/>
                 </a:solidFill>
@@ -3890,7 +3945,7 @@
               </a:rPr>
               <a:t>Pacote 8 reels/mês</a:t>
             </a:r>
-            <a:endParaRPr lang="en-US" sz="1700" dirty="0"/>
+            <a:endParaRPr lang="en-US" sz="1550" dirty="0"/>
           </a:p>
         </p:txBody>
       </p:sp>
@@ -3902,24 +3957,24 @@
         </p:nvSpPr>
         <p:spPr>
           <a:xfrm>
-            <a:off x="5120640" y="2606040"/>
-            <a:ext cx="3383280" cy="320040"/>
-          </a:xfrm>
-          <a:prstGeom prst="rect">
-            <a:avLst/>
-          </a:prstGeom>
-          <a:noFill/>
-          <a:ln/>
-        </p:spPr>
-        <p:txBody>
-          <a:bodyPr wrap="square" lIns="0" tIns="0" rIns="0" bIns="0" rtlCol="0" anchor="ctr"/>
-          <a:lstStyle/>
-          <a:p>
-            <a:pPr indent="0" marL="0">
-              <a:buNone/>
-            </a:pPr>
-            <a:r>
-              <a:rPr lang="en-US" sz="1250" dirty="0">
+            <a:off x="3712464" y="2578608"/>
+            <a:ext cx="2167128" cy="320040"/>
+          </a:xfrm>
+          <a:prstGeom prst="rect">
+            <a:avLst/>
+          </a:prstGeom>
+          <a:noFill/>
+          <a:ln/>
+        </p:spPr>
+        <p:txBody>
+          <a:bodyPr wrap="square" lIns="0" tIns="0" rIns="0" bIns="0" rtlCol="0" anchor="ctr"/>
+          <a:lstStyle/>
+          <a:p>
+            <a:pPr indent="0" marL="0">
+              <a:buNone/>
+            </a:pPr>
+            <a:r>
+              <a:rPr lang="en-US" sz="1100" dirty="0">
                 <a:solidFill>
                   <a:srgbClr val="3A3A3A"/>
                 </a:solidFill>
@@ -3929,7 +3984,7 @@
               </a:rPr>
               <a:t>›  8 reels editados por mês</a:t>
             </a:r>
-            <a:endParaRPr lang="en-US" sz="1250" dirty="0"/>
+            <a:endParaRPr lang="en-US" sz="1100" dirty="0"/>
           </a:p>
         </p:txBody>
       </p:sp>
@@ -3941,24 +3996,24 @@
         </p:nvSpPr>
         <p:spPr>
           <a:xfrm>
-            <a:off x="5120640" y="2971800"/>
-            <a:ext cx="3383280" cy="320040"/>
-          </a:xfrm>
-          <a:prstGeom prst="rect">
-            <a:avLst/>
-          </a:prstGeom>
-          <a:noFill/>
-          <a:ln/>
-        </p:spPr>
-        <p:txBody>
-          <a:bodyPr wrap="square" lIns="0" tIns="0" rIns="0" bIns="0" rtlCol="0" anchor="ctr"/>
-          <a:lstStyle/>
-          <a:p>
-            <a:pPr indent="0" marL="0">
-              <a:buNone/>
-            </a:pPr>
-            <a:r>
-              <a:rPr lang="en-US" sz="1250" dirty="0">
+            <a:off x="3712464" y="2916936"/>
+            <a:ext cx="2167128" cy="320040"/>
+          </a:xfrm>
+          <a:prstGeom prst="rect">
+            <a:avLst/>
+          </a:prstGeom>
+          <a:noFill/>
+          <a:ln/>
+        </p:spPr>
+        <p:txBody>
+          <a:bodyPr wrap="square" lIns="0" tIns="0" rIns="0" bIns="0" rtlCol="0" anchor="ctr"/>
+          <a:lstStyle/>
+          <a:p>
+            <a:pPr indent="0" marL="0">
+              <a:buNone/>
+            </a:pPr>
+            <a:r>
+              <a:rPr lang="en-US" sz="1100" dirty="0">
                 <a:solidFill>
                   <a:srgbClr val="3A3A3A"/>
                 </a:solidFill>
@@ -3968,7 +4023,7 @@
               </a:rPr>
               <a:t>›  Cortes, ritmo e legendas</a:t>
             </a:r>
-            <a:endParaRPr lang="en-US" sz="1250" dirty="0"/>
+            <a:endParaRPr lang="en-US" sz="1100" dirty="0"/>
           </a:p>
         </p:txBody>
       </p:sp>
@@ -3980,24 +4035,24 @@
         </p:nvSpPr>
         <p:spPr>
           <a:xfrm>
-            <a:off x="5120640" y="3337560"/>
-            <a:ext cx="3383280" cy="320040"/>
-          </a:xfrm>
-          <a:prstGeom prst="rect">
-            <a:avLst/>
-          </a:prstGeom>
-          <a:noFill/>
-          <a:ln/>
-        </p:spPr>
-        <p:txBody>
-          <a:bodyPr wrap="square" lIns="0" tIns="0" rIns="0" bIns="0" rtlCol="0" anchor="ctr"/>
-          <a:lstStyle/>
-          <a:p>
-            <a:pPr indent="0" marL="0">
-              <a:buNone/>
-            </a:pPr>
-            <a:r>
-              <a:rPr lang="en-US" sz="1250" dirty="0">
+            <a:off x="3712464" y="3255264"/>
+            <a:ext cx="2167128" cy="320040"/>
+          </a:xfrm>
+          <a:prstGeom prst="rect">
+            <a:avLst/>
+          </a:prstGeom>
+          <a:noFill/>
+          <a:ln/>
+        </p:spPr>
+        <p:txBody>
+          <a:bodyPr wrap="square" lIns="0" tIns="0" rIns="0" bIns="0" rtlCol="0" anchor="ctr"/>
+          <a:lstStyle/>
+          <a:p>
+            <a:pPr indent="0" marL="0">
+              <a:buNone/>
+            </a:pPr>
+            <a:r>
+              <a:rPr lang="en-US" sz="1100" dirty="0">
                 <a:solidFill>
                   <a:srgbClr val="3A3A3A"/>
                 </a:solidFill>
@@ -4007,7 +4062,7 @@
               </a:rPr>
               <a:t>›  R$ 50 por reel no pacote</a:t>
             </a:r>
-            <a:endParaRPr lang="en-US" sz="1250" dirty="0"/>
+            <a:endParaRPr lang="en-US" sz="1100" dirty="0"/>
           </a:p>
         </p:txBody>
       </p:sp>
@@ -4019,8 +4074,8 @@
         </p:nvSpPr>
         <p:spPr>
           <a:xfrm>
-            <a:off x="5120640" y="3749040"/>
-            <a:ext cx="3383280" cy="0"/>
+            <a:off x="3712464" y="3639312"/>
+            <a:ext cx="2167128" cy="0"/>
           </a:xfrm>
           <a:prstGeom prst="line">
             <a:avLst/>
@@ -4042,24 +4097,24 @@
         </p:nvSpPr>
         <p:spPr>
           <a:xfrm>
-            <a:off x="5120640" y="3886200"/>
-            <a:ext cx="3383280" cy="228600"/>
-          </a:xfrm>
-          <a:prstGeom prst="rect">
-            <a:avLst/>
-          </a:prstGeom>
-          <a:noFill/>
-          <a:ln/>
-        </p:spPr>
-        <p:txBody>
-          <a:bodyPr wrap="square" lIns="0" tIns="0" rIns="0" bIns="0" rtlCol="0" anchor="ctr"/>
-          <a:lstStyle/>
-          <a:p>
-            <a:pPr indent="0" marL="0">
-              <a:buNone/>
-            </a:pPr>
-            <a:r>
-              <a:rPr lang="en-US" sz="1000" spc="100" kern="0" dirty="0">
+            <a:off x="3712464" y="3776472"/>
+            <a:ext cx="2167128" cy="228600"/>
+          </a:xfrm>
+          <a:prstGeom prst="rect">
+            <a:avLst/>
+          </a:prstGeom>
+          <a:noFill/>
+          <a:ln/>
+        </p:spPr>
+        <p:txBody>
+          <a:bodyPr wrap="square" lIns="0" tIns="0" rIns="0" bIns="0" rtlCol="0" anchor="ctr"/>
+          <a:lstStyle/>
+          <a:p>
+            <a:pPr indent="0" marL="0">
+              <a:buNone/>
+            </a:pPr>
+            <a:r>
+              <a:rPr lang="en-US" sz="950" spc="100" kern="0" dirty="0">
                 <a:solidFill>
                   <a:srgbClr val="5A5A5A"/>
                 </a:solidFill>
@@ -4069,7 +4124,7 @@
               </a:rPr>
               <a:t>A PARTIR DE</a:t>
             </a:r>
-            <a:endParaRPr lang="en-US" sz="1000" dirty="0"/>
+            <a:endParaRPr lang="en-US" sz="950" dirty="0"/>
           </a:p>
         </p:txBody>
       </p:sp>
@@ -4081,24 +4136,24 @@
         </p:nvSpPr>
         <p:spPr>
           <a:xfrm>
-            <a:off x="5120640" y="4087368"/>
-            <a:ext cx="3383280" cy="457200"/>
-          </a:xfrm>
-          <a:prstGeom prst="rect">
-            <a:avLst/>
-          </a:prstGeom>
-          <a:noFill/>
-          <a:ln/>
-        </p:spPr>
-        <p:txBody>
-          <a:bodyPr wrap="square" lIns="0" tIns="0" rIns="0" bIns="0" rtlCol="0" anchor="ctr"/>
-          <a:lstStyle/>
-          <a:p>
-            <a:pPr indent="0" marL="0">
-              <a:buNone/>
-            </a:pPr>
-            <a:r>
-              <a:rPr lang="en-US" sz="2600" b="1" dirty="0">
+            <a:off x="3712464" y="3977640"/>
+            <a:ext cx="2167128" cy="411480"/>
+          </a:xfrm>
+          <a:prstGeom prst="rect">
+            <a:avLst/>
+          </a:prstGeom>
+          <a:noFill/>
+          <a:ln/>
+        </p:spPr>
+        <p:txBody>
+          <a:bodyPr wrap="square" lIns="0" tIns="0" rIns="0" bIns="0" rtlCol="0" anchor="ctr"/>
+          <a:lstStyle/>
+          <a:p>
+            <a:pPr indent="0" marL="0">
+              <a:buNone/>
+            </a:pPr>
+            <a:r>
+              <a:rPr lang="en-US" sz="2200" b="1" dirty="0">
                 <a:solidFill>
                   <a:srgbClr val="0D0D0D"/>
                 </a:solidFill>
@@ -4112,7 +4167,7 @@
               <a:buNone/>
             </a:pPr>
             <a:r>
-              <a:rPr lang="en-US" sz="1300" dirty="0">
+              <a:rPr lang="en-US" sz="1200" dirty="0">
                 <a:solidFill>
                   <a:srgbClr val="5A5A5A"/>
                 </a:solidFill>
@@ -4122,7 +4177,7 @@
               </a:rPr>
               <a:t>/mês</a:t>
             </a:r>
-            <a:endParaRPr lang="en-US" sz="2600" dirty="0"/>
+            <a:endParaRPr lang="en-US" sz="2200" dirty="0"/>
           </a:p>
         </p:txBody>
       </p:sp>
@@ -4134,24 +4189,24 @@
         </p:nvSpPr>
         <p:spPr>
           <a:xfrm>
-            <a:off x="5120640" y="4572000"/>
-            <a:ext cx="3383280" cy="274320"/>
-          </a:xfrm>
-          <a:prstGeom prst="rect">
-            <a:avLst/>
-          </a:prstGeom>
-          <a:noFill/>
-          <a:ln/>
-        </p:spPr>
-        <p:txBody>
-          <a:bodyPr wrap="square" lIns="0" tIns="0" rIns="0" bIns="0" rtlCol="0" anchor="ctr"/>
-          <a:lstStyle/>
-          <a:p>
-            <a:pPr indent="0" marL="0">
-              <a:buNone/>
-            </a:pPr>
-            <a:r>
-              <a:rPr lang="en-US" sz="1050" i="1" dirty="0">
+            <a:off x="3712464" y="4416552"/>
+            <a:ext cx="2167128" cy="274320"/>
+          </a:xfrm>
+          <a:prstGeom prst="rect">
+            <a:avLst/>
+          </a:prstGeom>
+          <a:noFill/>
+          <a:ln/>
+        </p:spPr>
+        <p:txBody>
+          <a:bodyPr wrap="square" lIns="0" tIns="0" rIns="0" bIns="0" rtlCol="0" anchor="ctr"/>
+          <a:lstStyle/>
+          <a:p>
+            <a:pPr indent="0" marL="0">
+              <a:buNone/>
+            </a:pPr>
+            <a:r>
+              <a:rPr lang="en-US" sz="950" i="1" dirty="0">
                 <a:solidFill>
                   <a:srgbClr val="5A5A5A"/>
                 </a:solidFill>
@@ -4161,13 +4216,339 @@
               </a:rPr>
               <a:t>equivalente a R$ 50 por reel</a:t>
             </a:r>
-            <a:endParaRPr lang="en-US" sz="1050" dirty="0"/>
-          </a:p>
-        </p:txBody>
-      </p:sp>
-      <p:sp>
-        <p:nvSpPr>
-          <p:cNvPr id="25" name="Text 23"/>
+            <a:endParaRPr lang="en-US" sz="950" dirty="0"/>
+          </a:p>
+        </p:txBody>
+      </p:sp>
+      <p:sp>
+        <p:nvSpPr>
+          <p:cNvPr id="25" name="Shape 23"/>
+          <p:cNvSpPr/>
+          <p:nvPr/>
+        </p:nvSpPr>
+        <p:spPr>
+          <a:xfrm>
+            <a:off x="6327648" y="1828800"/>
+            <a:ext cx="2624328" cy="3017520"/>
+          </a:xfrm>
+          <a:prstGeom prst="roundRect">
+            <a:avLst>
+              <a:gd name="adj" fmla="val 2439"/>
+            </a:avLst>
+          </a:prstGeom>
+          <a:solidFill>
+            <a:srgbClr val="FFFFFF"/>
+          </a:solidFill>
+          <a:ln w="12700">
+            <a:solidFill>
+              <a:srgbClr val="C9A24B"/>
+            </a:solidFill>
+            <a:prstDash val="solid"/>
+          </a:ln>
+        </p:spPr>
+      </p:sp>
+      <p:sp>
+        <p:nvSpPr>
+          <p:cNvPr id="26" name="Text 24"/>
+          <p:cNvSpPr/>
+          <p:nvPr/>
+        </p:nvSpPr>
+        <p:spPr>
+          <a:xfrm>
+            <a:off x="6556248" y="2103120"/>
+            <a:ext cx="2167128" cy="365760"/>
+          </a:xfrm>
+          <a:prstGeom prst="rect">
+            <a:avLst/>
+          </a:prstGeom>
+          <a:noFill/>
+          <a:ln/>
+        </p:spPr>
+        <p:txBody>
+          <a:bodyPr wrap="square" lIns="0" tIns="0" rIns="0" bIns="0" rtlCol="0" anchor="ctr"/>
+          <a:lstStyle/>
+          <a:p>
+            <a:pPr indent="0" marL="0">
+              <a:buNone/>
+            </a:pPr>
+            <a:r>
+              <a:rPr lang="en-US" sz="1550" b="1" dirty="0">
+                <a:solidFill>
+                  <a:srgbClr val="0D0D0D"/>
+                </a:solidFill>
+                <a:latin typeface="Calibri" pitchFamily="34" charset="0"/>
+                <a:ea typeface="Calibri" pitchFamily="34" charset="-122"/>
+                <a:cs typeface="Calibri" pitchFamily="34" charset="-120"/>
+              </a:rPr>
+              <a:t>Vídeo avulso</a:t>
+            </a:r>
+            <a:endParaRPr lang="en-US" sz="1550" dirty="0"/>
+          </a:p>
+        </p:txBody>
+      </p:sp>
+      <p:sp>
+        <p:nvSpPr>
+          <p:cNvPr id="27" name="Text 25"/>
+          <p:cNvSpPr/>
+          <p:nvPr/>
+        </p:nvSpPr>
+        <p:spPr>
+          <a:xfrm>
+            <a:off x="6556248" y="2578608"/>
+            <a:ext cx="2167128" cy="320040"/>
+          </a:xfrm>
+          <a:prstGeom prst="rect">
+            <a:avLst/>
+          </a:prstGeom>
+          <a:noFill/>
+          <a:ln/>
+        </p:spPr>
+        <p:txBody>
+          <a:bodyPr wrap="square" lIns="0" tIns="0" rIns="0" bIns="0" rtlCol="0" anchor="ctr"/>
+          <a:lstStyle/>
+          <a:p>
+            <a:pPr indent="0" marL="0">
+              <a:buNone/>
+            </a:pPr>
+            <a:r>
+              <a:rPr lang="en-US" sz="1100" dirty="0">
+                <a:solidFill>
+                  <a:srgbClr val="3A3A3A"/>
+                </a:solidFill>
+                <a:latin typeface="Calibri" pitchFamily="34" charset="0"/>
+                <a:ea typeface="Calibri" pitchFamily="34" charset="-122"/>
+                <a:cs typeface="Calibri" pitchFamily="34" charset="-120"/>
+              </a:rPr>
+              <a:t>›  1 reel editado, sem pacote</a:t>
+            </a:r>
+            <a:endParaRPr lang="en-US" sz="1100" dirty="0"/>
+          </a:p>
+        </p:txBody>
+      </p:sp>
+      <p:sp>
+        <p:nvSpPr>
+          <p:cNvPr id="28" name="Text 26"/>
+          <p:cNvSpPr/>
+          <p:nvPr/>
+        </p:nvSpPr>
+        <p:spPr>
+          <a:xfrm>
+            <a:off x="6556248" y="2916936"/>
+            <a:ext cx="2167128" cy="320040"/>
+          </a:xfrm>
+          <a:prstGeom prst="rect">
+            <a:avLst/>
+          </a:prstGeom>
+          <a:noFill/>
+          <a:ln/>
+        </p:spPr>
+        <p:txBody>
+          <a:bodyPr wrap="square" lIns="0" tIns="0" rIns="0" bIns="0" rtlCol="0" anchor="ctr"/>
+          <a:lstStyle/>
+          <a:p>
+            <a:pPr indent="0" marL="0">
+              <a:buNone/>
+            </a:pPr>
+            <a:r>
+              <a:rPr lang="en-US" sz="1100" dirty="0">
+                <a:solidFill>
+                  <a:srgbClr val="3A3A3A"/>
+                </a:solidFill>
+                <a:latin typeface="Calibri" pitchFamily="34" charset="0"/>
+                <a:ea typeface="Calibri" pitchFamily="34" charset="-122"/>
+                <a:cs typeface="Calibri" pitchFamily="34" charset="-120"/>
+              </a:rPr>
+              <a:t>›  Cortes, ritmo e legendas</a:t>
+            </a:r>
+            <a:endParaRPr lang="en-US" sz="1100" dirty="0"/>
+          </a:p>
+        </p:txBody>
+      </p:sp>
+      <p:sp>
+        <p:nvSpPr>
+          <p:cNvPr id="29" name="Text 27"/>
+          <p:cNvSpPr/>
+          <p:nvPr/>
+        </p:nvSpPr>
+        <p:spPr>
+          <a:xfrm>
+            <a:off x="6556248" y="3255264"/>
+            <a:ext cx="2167128" cy="320040"/>
+          </a:xfrm>
+          <a:prstGeom prst="rect">
+            <a:avLst/>
+          </a:prstGeom>
+          <a:noFill/>
+          <a:ln/>
+        </p:spPr>
+        <p:txBody>
+          <a:bodyPr wrap="square" lIns="0" tIns="0" rIns="0" bIns="0" rtlCol="0" anchor="ctr"/>
+          <a:lstStyle/>
+          <a:p>
+            <a:pPr indent="0" marL="0">
+              <a:buNone/>
+            </a:pPr>
+            <a:r>
+              <a:rPr lang="en-US" sz="1100" dirty="0">
+                <a:solidFill>
+                  <a:srgbClr val="3A3A3A"/>
+                </a:solidFill>
+                <a:latin typeface="Calibri" pitchFamily="34" charset="0"/>
+                <a:ea typeface="Calibri" pitchFamily="34" charset="-122"/>
+                <a:cs typeface="Calibri" pitchFamily="34" charset="-120"/>
+              </a:rPr>
+              <a:t>›  Ideal para demanda pontual</a:t>
+            </a:r>
+            <a:endParaRPr lang="en-US" sz="1100" dirty="0"/>
+          </a:p>
+        </p:txBody>
+      </p:sp>
+      <p:sp>
+        <p:nvSpPr>
+          <p:cNvPr id="30" name="Shape 28"/>
+          <p:cNvSpPr/>
+          <p:nvPr/>
+        </p:nvSpPr>
+        <p:spPr>
+          <a:xfrm>
+            <a:off x="6556248" y="3639312"/>
+            <a:ext cx="2167128" cy="0"/>
+          </a:xfrm>
+          <a:prstGeom prst="line">
+            <a:avLst/>
+          </a:prstGeom>
+          <a:noFill/>
+          <a:ln w="9525">
+            <a:solidFill>
+              <a:srgbClr val="C9A24B"/>
+            </a:solidFill>
+            <a:prstDash val="dash"/>
+          </a:ln>
+        </p:spPr>
+      </p:sp>
+      <p:sp>
+        <p:nvSpPr>
+          <p:cNvPr id="31" name="Text 29"/>
+          <p:cNvSpPr/>
+          <p:nvPr/>
+        </p:nvSpPr>
+        <p:spPr>
+          <a:xfrm>
+            <a:off x="6556248" y="3776472"/>
+            <a:ext cx="2167128" cy="228600"/>
+          </a:xfrm>
+          <a:prstGeom prst="rect">
+            <a:avLst/>
+          </a:prstGeom>
+          <a:noFill/>
+          <a:ln/>
+        </p:spPr>
+        <p:txBody>
+          <a:bodyPr wrap="square" lIns="0" tIns="0" rIns="0" bIns="0" rtlCol="0" anchor="ctr"/>
+          <a:lstStyle/>
+          <a:p>
+            <a:pPr indent="0" marL="0">
+              <a:buNone/>
+            </a:pPr>
+            <a:r>
+              <a:rPr lang="en-US" sz="950" spc="100" kern="0" dirty="0">
+                <a:solidFill>
+                  <a:srgbClr val="5A5A5A"/>
+                </a:solidFill>
+                <a:latin typeface="Calibri" pitchFamily="34" charset="0"/>
+                <a:ea typeface="Calibri" pitchFamily="34" charset="-122"/>
+                <a:cs typeface="Calibri" pitchFamily="34" charset="-120"/>
+              </a:rPr>
+              <a:t>POR VÍDEO</a:t>
+            </a:r>
+            <a:endParaRPr lang="en-US" sz="950" dirty="0"/>
+          </a:p>
+        </p:txBody>
+      </p:sp>
+      <p:sp>
+        <p:nvSpPr>
+          <p:cNvPr id="32" name="Text 30"/>
+          <p:cNvSpPr/>
+          <p:nvPr/>
+        </p:nvSpPr>
+        <p:spPr>
+          <a:xfrm>
+            <a:off x="6556248" y="3977640"/>
+            <a:ext cx="2167128" cy="411480"/>
+          </a:xfrm>
+          <a:prstGeom prst="rect">
+            <a:avLst/>
+          </a:prstGeom>
+          <a:noFill/>
+          <a:ln/>
+        </p:spPr>
+        <p:txBody>
+          <a:bodyPr wrap="square" lIns="0" tIns="0" rIns="0" bIns="0" rtlCol="0" anchor="ctr"/>
+          <a:lstStyle/>
+          <a:p>
+            <a:pPr indent="0" marL="0">
+              <a:buNone/>
+            </a:pPr>
+            <a:r>
+              <a:rPr lang="en-US" sz="2200" b="1" dirty="0">
+                <a:solidFill>
+                  <a:srgbClr val="0D0D0D"/>
+                </a:solidFill>
+                <a:latin typeface="Cambria" pitchFamily="34" charset="0"/>
+                <a:ea typeface="Cambria" pitchFamily="34" charset="-122"/>
+                <a:cs typeface="Cambria" pitchFamily="34" charset="-120"/>
+              </a:rPr>
+              <a:t>R$ 65</a:t>
+            </a:r>
+            <a:pPr indent="0" marL="0">
+              <a:buNone/>
+            </a:pPr>
+            <a:endParaRPr lang="en-US" sz="2200" dirty="0"/>
+          </a:p>
+        </p:txBody>
+      </p:sp>
+      <p:sp>
+        <p:nvSpPr>
+          <p:cNvPr id="33" name="Text 31"/>
+          <p:cNvSpPr/>
+          <p:nvPr/>
+        </p:nvSpPr>
+        <p:spPr>
+          <a:xfrm>
+            <a:off x="6556248" y="4416552"/>
+            <a:ext cx="2167128" cy="274320"/>
+          </a:xfrm>
+          <a:prstGeom prst="rect">
+            <a:avLst/>
+          </a:prstGeom>
+          <a:noFill/>
+          <a:ln/>
+        </p:spPr>
+        <p:txBody>
+          <a:bodyPr wrap="square" lIns="0" tIns="0" rIns="0" bIns="0" rtlCol="0" anchor="ctr"/>
+          <a:lstStyle/>
+          <a:p>
+            <a:pPr indent="0" marL="0">
+              <a:buNone/>
+            </a:pPr>
+            <a:r>
+              <a:rPr lang="en-US" sz="950" i="1" dirty="0">
+                <a:solidFill>
+                  <a:srgbClr val="5A5A5A"/>
+                </a:solidFill>
+                <a:latin typeface="Calibri" pitchFamily="34" charset="0"/>
+                <a:ea typeface="Calibri" pitchFamily="34" charset="-122"/>
+                <a:cs typeface="Calibri" pitchFamily="34" charset="-120"/>
+              </a:rPr>
+              <a:t>sem compromisso mensal</a:t>
+            </a:r>
+            <a:endParaRPr lang="en-US" sz="950" dirty="0"/>
+          </a:p>
+        </p:txBody>
+      </p:sp>
+      <p:sp>
+        <p:nvSpPr>
+          <p:cNvPr id="34" name="Text 32"/>
           <p:cNvSpPr/>
           <p:nvPr/>
         </p:nvSpPr>
@@ -4632,7 +5013,7 @@
                 <a:ea typeface="Calibri" pitchFamily="34" charset="-122"/>
                 <a:cs typeface="Calibri" pitchFamily="34" charset="-120"/>
               </a:rPr>
-              <a:t>Também pode ser pago sempre na entrega dos materiais do mês — o que for mais prático para a empresa.</a:t>
+              <a:t>Também pode ser pago sempre na entrega dos materiais do mês, o que for mais prático para a empresa.</a:t>
             </a:r>
             <a:endParaRPr lang="en-US" sz="1200" dirty="0"/>
           </a:p>
@@ -5006,7 +5387,7 @@
                 <a:ea typeface="Calibri" pitchFamily="34" charset="-122"/>
                 <a:cs typeface="Calibri" pitchFamily="34" charset="-120"/>
               </a:rPr>
-              <a:t>RECRIA, AGÊNCIA DE EDIÇÃO DE VÍDEO</a:t>
+              <a:t>RECRIA, AGÊNCIA DE MARKETING</a:t>
             </a:r>
             <a:endParaRPr lang="en-US" sz="1100" dirty="0"/>
           </a:p>

</xml_diff>

<commit_message>
Ajusta capa (só logo, sem texto duplicado) e detalhes finais da proposta
- Remove texto "RECRIA" ao lado do logo na capa (mantém só a marca)
- Adiciona "gestora de tráfego" à lista de frentes de marketing
- Simplifica o botão do portfólio para "VER PORTFÓLIO", sem seta
</commit_message>
<xml_diff>
--- a/propostas/Recria - Proposta Edicao de Video.pptx
+++ b/propostas/Recria - Proposta Edicao de Video.pptx
@@ -1445,8 +1445,8 @@
         </p:blipFill>
         <p:spPr>
           <a:xfrm>
-            <a:off x="640080" y="457200"/>
-            <a:ext cx="457200" cy="329184"/>
+            <a:off x="640080" y="384048"/>
+            <a:ext cx="914400" cy="658368"/>
           </a:xfrm>
           <a:prstGeom prst="rect">
             <a:avLst/>
@@ -1455,46 +1455,7 @@
       </p:pic>
       <p:sp>
         <p:nvSpPr>
-          <p:cNvPr id="4" name="Text 1"/>
-          <p:cNvSpPr/>
-          <p:nvPr/>
-        </p:nvSpPr>
-        <p:spPr>
-          <a:xfrm>
-            <a:off x="1188720" y="411480"/>
-            <a:ext cx="2743200" cy="411480"/>
-          </a:xfrm>
-          <a:prstGeom prst="rect">
-            <a:avLst/>
-          </a:prstGeom>
-          <a:noFill/>
-          <a:ln/>
-        </p:spPr>
-        <p:txBody>
-          <a:bodyPr wrap="square" lIns="0" tIns="0" rIns="0" bIns="0" rtlCol="0" anchor="ctr"/>
-          <a:lstStyle/>
-          <a:p>
-            <a:pPr indent="0" marL="0">
-              <a:buNone/>
-            </a:pPr>
-            <a:r>
-              <a:rPr lang="en-US" sz="2000" b="1" dirty="0">
-                <a:solidFill>
-                  <a:srgbClr val="C9A24B"/>
-                </a:solidFill>
-                <a:latin typeface="Cambria" pitchFamily="34" charset="0"/>
-                <a:ea typeface="Cambria" pitchFamily="34" charset="-122"/>
-                <a:cs typeface="Cambria" pitchFamily="34" charset="-120"/>
-              </a:rPr>
-              <a:t>RECRIA</a:t>
-            </a:r>
-            <a:endParaRPr lang="en-US" sz="2000" dirty="0"/>
-          </a:p>
-        </p:txBody>
-      </p:sp>
-      <p:sp>
-        <p:nvSpPr>
-          <p:cNvPr id="5" name="Shape 2"/>
+          <p:cNvPr id="4" name="Shape 1"/>
           <p:cNvSpPr/>
           <p:nvPr/>
         </p:nvSpPr>
@@ -1517,7 +1478,7 @@
       </p:sp>
       <p:sp>
         <p:nvSpPr>
-          <p:cNvPr id="6" name="Text 3"/>
+          <p:cNvPr id="5" name="Text 2"/>
           <p:cNvSpPr/>
           <p:nvPr/>
         </p:nvSpPr>
@@ -1556,7 +1517,7 @@
       </p:sp>
       <p:sp>
         <p:nvSpPr>
-          <p:cNvPr id="7" name="Text 4"/>
+          <p:cNvPr id="6" name="Text 3"/>
           <p:cNvSpPr/>
           <p:nvPr/>
         </p:nvSpPr>
@@ -1595,7 +1556,7 @@
       </p:sp>
       <p:sp>
         <p:nvSpPr>
-          <p:cNvPr id="8" name="Text 5"/>
+          <p:cNvPr id="7" name="Text 4"/>
           <p:cNvSpPr/>
           <p:nvPr/>
         </p:nvSpPr>
@@ -1634,7 +1595,7 @@
       </p:sp>
       <p:sp>
         <p:nvSpPr>
-          <p:cNvPr id="9" name="Text 6"/>
+          <p:cNvPr id="8" name="Text 5"/>
           <p:cNvSpPr/>
           <p:nvPr/>
         </p:nvSpPr>
@@ -2045,7 +2006,7 @@
                 <a:ea typeface="Calibri" pitchFamily="34" charset="-122"/>
                 <a:cs typeface="Calibri" pitchFamily="34" charset="-120"/>
               </a:rPr>
-              <a:t>Passou por praticamente todas as frentes de marketing: estrategista, copywriter, designer, social media, audiovisual e roteirista.</a:t>
+              <a:t>Passou por praticamente todas as frentes de marketing: estrategista, copywriter, designer, social media, gestora de tráfego, audiovisual e roteirista.</a:t>
             </a:r>
             <a:endParaRPr lang="en-US" sz="1350" dirty="0"/>
           </a:p>
@@ -2565,7 +2526,7 @@
                   </a:extLst>
                 </a:hlinkClick>
               </a:rPr>
-              <a:t>VER PORTFÓLIO DE REELS →</a:t>
+              <a:t>VER PORTFÓLIO</a:t>
             </a:r>
             <a:endParaRPr lang="en-US" sz="1250" dirty="0"/>
           </a:p>

</xml_diff>